<commit_message>
Correct Crown CICRA conditions and volatility sequence
</commit_message>
<xml_diff>
--- a/examples/crown-castle-2025/deliverables/presentation.pptx
+++ b/examples/crown-castle-2025/deliverables/presentation.pptx
@@ -607,6 +607,9 @@
             <a:r>
               <a:rPr lang="en-US" dirty="0"/>
               <a:t>底稿 F05, F08, F09, F15, F17
+[F05] supported / [F08] supported / [F09] conditional / [F15] conditional / [F17] conditional
+底稿 F05 / F08 / F09 / F15 / F17；来源 S25 / SQ126 / SSALE / SPROFORMA / SSPA / SCREDIT / SOLDCREDIT / S_SP_RATIOS / S_SP_XBRL / S_SP_Q4 / S_SP_SECTORS / S_SP_Q1
+原文定位、URL及完整引用见本页备注；完整方法和明细见同名底稿及 Word/Excel。
 [E25CASH] Crown Castle 2025 Form 10-K | note 16，印刷及 PDF p88，cash reconciliation table
 https://investor.crowncastle.com/static-files/68fb84e1-1dac-440d-96b4-55b9603e10dd
 [E25DEBT] Crown Castle 2025 Form 10-K | note 8，p75–79 债务表、2018 Tower Revenue Notes、CP Program；MD&amp;A p40/p45
@@ -772,6 +775,9 @@
             <a:r>
               <a:rPr lang="en-US" dirty="0"/>
               <a:t>底稿 F01, F02, F03, C_contnimove, saleloss2025
+[F01] supported / [F02] supported / [F03] supported
+底稿 F01 / F02 / F03；来源 S25 / SSEC / S24 / SFASB / SSPA / SPROFORMA / SQ126
+原文定位、URL及完整引用见本页备注；完整方法和明细见同名底稿及 Word/Excel。
 [E25PL] Crown Castle 2025 Form 10-K | 印刷及 PDF p59，Consolidated Statement of Operations and Comprehensive Income
 https://investor.crowncastle.com/static-files/68fb84e1-1dac-440d-96b4-55b9603e10dd
 [ESECSEQ] Crown Castle 2025-06-04 SEC comment-response letter | 公司回复 Staff comment 1；引用 ASC350-20-35-31 和 ASC360-10-35-17
@@ -888,6 +894,9 @@
             <a:r>
               <a:rPr lang="en-US" dirty="0"/>
               <a:t>底稿 F04, F05, F12, cash2025, C_cashdiv_2025, cashend2025
+[F04] supported / [F05] supported / [F12] supported
+底稿 F04 / F05 / F12；来源 S25
+原文定位、URL及完整引用见本页备注；完整方法和明细见同名底稿及 Word/Excel。
 [E25BS] Crown Castle 2025 Form 10-K | 印刷及 PDF p58，Consolidated Balance Sheet，2025/2024 两列
 https://investor.crowncastle.com/static-files/68fb84e1-1dac-440d-96b4-55b9603e10dd
 [E25CF] Crown Castle 2025 Form 10-K | 印刷及 PDF p60，Consolidated Statement of Cash Flows
@@ -994,6 +1003,9 @@
             <a:r>
               <a:rPr lang="en-US" dirty="0"/>
               <a:t>底稿 F08, F15, C_saleproceeds, debtrepaid, costpaid, C_pf_cash
+[F08] supported / [F15] conditional
+底稿 F08 / F15；来源 SQ126 / SPROFORMA / SSALE / S25 / SSPA / S_SP_RATIOS / S_SP_XBRL
+原文定位、URL及完整引用见本页备注；完整方法和明细见同名底稿及 Word/Excel。
 [EQ126SALE] Crown Castle Q1 2026 Form 10-Q | note 14 印刷 p19/PDF p20，Completion of Strategic Fiber Transaction
 https://investor.crowncastle.com/static-files/de60fca2-89d5-499d-899b-8e0a23030617
 [EPROBASIS] 2026-05-01 出售8-K及Exhibit99.2公开未经审计备考 | Ex99.2 PDF p18编制基础；p21 Note1
@@ -1126,6 +1138,9 @@
             <a:r>
               <a:rPr lang="en-US" dirty="0"/>
               <a:t>底稿 F06, F07, F09, C_headroom2025, C_newnetLC, leverage2025, limit2025
+[F06] conditional / [F07] supported / [F09] conditional
+底稿 F06 / F07 / F09；来源 S25 / SOLDCREDIT / SCREDIT / SQ126 / SPROFORMA
+原文定位、URL及完整引用见本页备注；完整方法和明细见同名底稿及 Word/Excel。
 [E25COV] Crown Castle 2025 Form 10-K | MD&amp;A p45 covenant table 及脚注
 https://investor.crowncastle.com/static-files/68fb84e1-1dac-440d-96b4-55b9603e10dd
 [EOLDCREDIT] 2022-07-08 Amendment No.7及附后旧信用协议 | §1.01定义：印刷p13–17/27–28/40/44/50–52；§1.04/1.05 p55–56；§6.09/6.10 p129
@@ -1234,6 +1249,9 @@
             <a:r>
               <a:rPr lang="en-US" dirty="0"/>
               <a:t>底稿 F13, F14, F15, sp_ebitda, sp_leverage, sp_ffo, sp_focf
+[F13] conditional / [F14] conditional / [F15] conditional
+底稿 F13 / F14 / F15；来源 S25 / S_SP_RATIOS / S_SP_XBRL / SPROFORMA / SQ126
+原文定位、URL及完整引用见本页备注；完整方法和明细见同名底稿及 Word/Excel。
 [E25BS] Crown Castle 2025 Form 10-K | 印刷及 PDF p58，Consolidated Balance Sheet，2025/2024 两列
 https://investor.crowncastle.com/static-files/68fb84e1-1dac-440d-96b4-55b9603e10dd
 [E25CF] Crown Castle 2025 Form 10-K | 印刷及 PDF p60，Consolidated Statement of Cash Flows
@@ -1354,6 +1372,9 @@
             <a:r>
               <a:rPr lang="en-US" dirty="0"/>
               <a:t>底稿 F11, F16, F17, C_sp_q1_cfo_change, C_sp_renew_share
+[F11] conditional / [F16] supported / [F17] conditional
+底稿 F11 / F16 / F17；来源 SQ126 / S_SP_Q4 / S25 / S_SP_Q1 / S_SP_SECTORS
+原文定位、URL及完整引用见本页备注；完整方法和明细见同名底稿及 Word/Excel。
 [E_SP_Q1CFO] Crown Castle Q1 2026 Form 10-Q | PDF6/印刷p5，2026Q1/2025Q1现金流表；PDF19–20/印刷p18–19，note13重组事项
 https://investor.crowncastle.com/static-files/de60fca2-89d5-499d-899b-8e0a23030617
 [E_SP_RENEW] Crown Castle Q4 2025 Supplemental Information | PDF13/印刷p12；TENANT OVERVIEW及脚注(a)–(f)
@@ -1454,6 +1475,9 @@
             <a:r>
               <a:rPr lang="en-US" dirty="0"/>
               <a:t>底稿 F10, F12, F06, F09, F14, F15, F17
+[F10] unresolved / [F12] supported / [F06] conditional / [F09] conditional / [F14] conditional / [F15] conditional / [F17] conditional
+底稿 F10 / F12 / F06 / F09 / F14 / F15 / F17；来源 S24 / S25 / SQ125 / SSEC / SQ126 / SOLDCREDIT / SCREDIT / SPROFORMA / S_SP_RATIOS / S_SP_XBRL / S_SP_Q4 / S_SP_SECTORS / S_SP_Q1
+原文定位、URL及完整引用见本页备注；完整方法和明细见同名底稿及 Word/Excel。
 [E24ORIG] Crown Castle 2024 Form 10-K（原报） | 原报 p61 合并损益；note 14/p88–89 segment results，分部表p89
 https://investor.crowncastle.com/static-files/baed4489-6578-4e32-81e6-a084eea66a02
 [E25PL] Crown Castle 2025 Form 10-K | 印刷及 PDF p59，Consolidated Statement of Operations and Comprehensive Income
@@ -5449,41 +5473,41 @@
                   <a:srgbClr val="1F2933"/>
                 </a:solidFill>
               </a:rPr>
-              <a:t>当年必然损失。土地控制与迁移成本可能缓释风险；medial仅</a:t>
-            </a:r>
-            <a:endParaRPr lang="en-US" sz="1800" dirty="0"/>
-          </a:p>
-          <a:p>
-            <a:pPr indent="0" marL="0">
-              <a:lnSpc>
-                <a:spcPct val="100000"/>
-              </a:lnSpc>
-              <a:buNone/>
-            </a:pPr>
-            <a:r>
-              <a:rPr lang="en-US" sz="1800" dirty="0">
-                <a:solidFill>
-                  <a:srgbClr val="1F2933"/>
-                </a:solidFill>
-              </a:rPr>
-              <a:t>是待验证候选，须核竞争地位、可预测CFO归属及续约情景，不能</a:t>
-            </a:r>
-            <a:endParaRPr lang="en-US" sz="1800" dirty="0"/>
-          </a:p>
-          <a:p>
-            <a:pPr indent="0" marL="0">
-              <a:lnSpc>
-                <a:spcPct val="100000"/>
-              </a:lnSpc>
-              <a:buNone/>
-            </a:pPr>
-            <a:r>
-              <a:rPr lang="en-US" sz="1800" dirty="0">
-                <a:solidFill>
-                  <a:srgbClr val="1F2933"/>
-                </a:solidFill>
-              </a:rPr>
-              <a:t>直接定档。</a:t>
+              <a:t>当年必然损失。土地控制与迁移成本可能缓释风险；先核low全部</a:t>
+            </a:r>
+            <a:endParaRPr lang="en-US" sz="1800" dirty="0"/>
+          </a:p>
+          <a:p>
+            <a:pPr indent="0" marL="0">
+              <a:lnSpc>
+                <a:spcPct val="100000"/>
+              </a:lnSpc>
+              <a:buNone/>
+            </a:pPr>
+            <a:r>
+              <a:rPr lang="en-US" sz="1800" dirty="0">
+                <a:solidFill>
+                  <a:srgbClr val="1F2933"/>
+                </a:solidFill>
+              </a:rPr>
+              <a:t>条件，再检验medial或standard。本案CICRA、</a:t>
+            </a:r>
+            <a:endParaRPr lang="en-US" sz="1800" dirty="0"/>
+          </a:p>
+          <a:p>
+            <a:pPr indent="0" marL="0">
+              <a:lnSpc>
+                <a:spcPct val="100000"/>
+              </a:lnSpc>
+              <a:buNone/>
+            </a:pPr>
+            <a:r>
+              <a:rPr lang="en-US" sz="1800" dirty="0">
+                <a:solidFill>
+                  <a:srgbClr val="1F2933"/>
+                </a:solidFill>
+              </a:rPr>
+              <a:t>竞争地位、可预测CFO归属及续约情景尚未完成，不能直接定档。</a:t>
             </a:r>
             <a:endParaRPr lang="en-US" sz="1800" dirty="0"/>
           </a:p>

</xml_diff>

<commit_message>
Expose methodology identity in Crown research presentation
</commit_message>
<xml_diff>
--- a/examples/crown-castle-2025/deliverables/presentation.pptx
+++ b/examples/crown-castle-2025/deliverables/presentation.pptx
@@ -21,9 +21,10 @@
     <p:sldId id="269" r:id="rId15"/>
     <p:sldId id="270" r:id="rId16"/>
     <p:sldId id="271" r:id="rId17"/>
+    <p:sldId id="272" r:id="rId18"/>
   </p:sldIdLst>
   <p:notesMasterIdLst>
-    <p:notesMasterId r:id="rId18"/>
+    <p:notesMasterId r:id="rId19"/>
   </p:notesMasterIdLst>
   <p:sldSz cx="12192000" cy="6858000"/>
   <p:notesSz cx="6858000" cy="12192000"/>
@@ -1690,6 +1691,185 @@
             <a:fld id="{F7021451-1387-4CA6-816F-3879F97B5CBC}" type="slidenum">
               <a:rPr lang="en-US"/>
               <a:t>16</a:t>
+            </a:fld>
+            <a:endParaRPr lang="en-US"/>
+          </a:p>
+        </p:txBody>
+      </p:sp>
+    </p:spTree>
+    <p:extLst>
+      <p:ext uri="{BB962C8B-B14F-4D97-AF65-F5344CB8AC3E}">
+        <p14:creationId xmlns:p14="http://schemas.microsoft.com/office/powerpoint/2010/main" val="1024086991"/>
+      </p:ext>
+    </p:extLst>
+  </p:cSld>
+  <p:clrMapOvr>
+    <a:masterClrMapping/>
+  </p:clrMapOvr>
+</p:notes>
+</file>
+
+<file path=ppt/notesSlides/notesSlide17.xml><?xml version="1.0" encoding="utf-8"?>
+<p:notes xmlns:a="http://schemas.openxmlformats.org/drawingml/2006/main" xmlns:r="http://schemas.openxmlformats.org/officeDocument/2006/relationships" xmlns:p="http://schemas.openxmlformats.org/presentationml/2006/main">
+  <p:cSld>
+    <p:spTree>
+      <p:nvGrpSpPr>
+        <p:cNvPr id="1" name=""/>
+        <p:cNvGrpSpPr/>
+        <p:nvPr/>
+      </p:nvGrpSpPr>
+      <p:grpSpPr>
+        <a:xfrm>
+          <a:off x="0" y="0"/>
+          <a:ext cx="0" cy="0"/>
+          <a:chOff x="0" y="0"/>
+          <a:chExt cx="0" cy="0"/>
+        </a:xfrm>
+      </p:grpSpPr>
+      <p:sp>
+        <p:nvSpPr>
+          <p:cNvPr id="2" name="Slide Image Placeholder 1"/>
+          <p:cNvSpPr>
+            <a:spLocks noGrp="1" noRot="1" noChangeAspect="1"/>
+          </p:cNvSpPr>
+          <p:nvPr>
+            <p:ph type="sldImg"/>
+          </p:nvPr>
+        </p:nvSpPr>
+        <p:spPr/>
+      </p:sp>
+      <p:sp>
+        <p:nvSpPr>
+          <p:cNvPr id="3" name="Notes Placeholder 2"/>
+          <p:cNvSpPr>
+            <a:spLocks noGrp="1"/>
+          </p:cNvSpPr>
+          <p:nvPr>
+            <p:ph type="body" idx="1"/>
+          </p:nvPr>
+        </p:nvSpPr>
+        <p:spPr/>
+        <p:txBody>
+          <a:bodyPr/>
+          <a:lstStyle/>
+          <a:p>
+            <a:r>
+              <a:rPr lang="en-US" dirty="0"/>
+              <a:t>底稿 F05, FF_R109_ISSUER, FF_R109_NOTE, F10, FF_FORWARD_STRESS
+[F05] conditional / [FF_R109_ISSUER] conditional / [FF_R109_NOTE] conditional / [F10] unresolved / [FF_FORWARD_STRESS] conditional
+底稿 F05 / FF_R109_ISSUER / FF_R109_NOTE / F10 / FF_FORWARD_STRESS；来源 S_DEV_LIQ / SCREDIT / SPROFORMA / S25 / SQ126 / S_SP_Q1 / S_SP_RATIOS / S_SP_XBRL / S_DEV_CORP / S_SP_SECTORS / S_DEV_REC / S_PROXY26 / S_DEV_COUNTRY / S24 / SQ125 / SSEC / S_SP_Q4
+原文定位、URL及完整引用见本页备注；完整方法和明细见同名底稿及 Word/Excel。
+[E_R109_LIQ] Methodology And Assumptions: Liquidity Descriptors For Global Corporate Issuers | PDF4–5/¶22–32；PDF7–14/¶37–50、64、73–90
+urn:sha256:76cf8f47d56b21e8fe60597490f873d1af5dd4ff1326b9a4fa2577c022a534d4
+[E_DEV_CREDIT] Crown Castle May 1 2026 Form 8-K and Exhibit 10.1 credit agreement | PDF11、22–24、40–41、49、51、103、118及公开8K摘要
+https://investor.crowncastle.com/static-files/dd7712df-51aa-4a29-b6a5-67becf7b2234
+[E_DEV_SALE] 2026-05-01 出售8-K及Exhibit99.2公开未经审计备考 | PDF2/5–9；已读相关备考章节
+https://investor.crowncastle.com/static-files/f4ff727f-0f13-4f18-affa-1ff461698ccf
+[E25BS] Crown Castle 2025 Form 10-K | 印刷及 PDF p58，Consolidated Balance Sheet，2025/2024 两列
+https://investor.crowncastle.com/static-files/68fb84e1-1dac-440d-96b4-55b9603e10dd
+[ECREDIT] Crown Castle May 1 2026 Form 8-K and Exhibit 10.1 credit agreement | 8-K Item 1.01；协议 §1.01、§1.04/p43、§1.05/p44、§4.02/p93、§6.10/p108；Total Indebtedness印刷39/PDF49，§1.04印刷43/PDF53
+https://investor.crowncastle.com/static-files/dd7712df-51aa-4a29-b6a5-67becf7b2234
+[EQ126CF] Crown Castle Q1 2026 Form 10-Q | 印刷 p18/PDF p19 现金调节；note 5/p12 债务；MD&amp;A/p28 流动性
+https://investor.crowncastle.com/static-files/de60fca2-89d5-499d-899b-8e0a23030617
+[EQ126FAC] Crown Castle Q1 2026 Form 10-Q | note 14 印刷 p20/PDF p21；MD&amp;A/p28 May 5 balances
+https://investor.crowncastle.com/static-files/de60fca2-89d5-499d-899b-8e0a23030617
+[EQ126SALE] Crown Castle Q1 2026 Form 10-Q | note 14 印刷 p19/PDF p20，Completion of Strategic Fiber Transaction
+https://investor.crowncastle.com/static-files/de60fca2-89d5-499d-899b-8e0a23030617
+[E_FWD_CASH_TAX] Crown Castle Q1 2026 Supplemental Information | Q1 supplement PDF12/印刷11完整Consolidated ROIC表及(a)–(f)脚注；PDF23/印刷22 Non-GAAP Measures定义
+https://investor.crowncastle.com/static-files/38f6a584-60a8-452d-bfd2-a44103aeec82
+[E_FWD_CONTRACT] Crown Castle Q1 2026 Supplemental Information | PDF9/11/13–16/18/28，印刷8/10/12–15/17/27
+https://investor.crowncastle.com/static-files/38f6a584-60a8-452d-bfd2-a44103aeec82
+[E_FWD_CREDIT_CONDITIONS] Crown Castle May 1 2026 Form 8-K and Exhibit 10.1 credit agreement | 完整协议PDF2、49、51、103、118；协议印刷39、41、93、108；§4.02/§6.10
+https://investor.crowncastle.com/static-files/dd7712df-51aa-4a29-b6a5-67becf7b2234
+[E_FWD_DEBT_MEASURE] S&amp;P Corporate Methodology: Ratios And Adjustments | PDF27/印刷27，Appendix2 Initial measurement / debt at fair value
+https://www.maalot.co.il/Publications/MT20251223092257.pdf
+[E_FWD_GUIDANCE] 2026-05-01 出售8-K及Exhibit99.2公开未经审计备考 | 完整May1 8-K的Ex99.1 PDF6、11、13、15–16（印刷2、7、9、11–12）
+https://investor.crowncastle.com/static-files/f4ff727f-0f13-4f18-affa-1ff461698ccf
+[E_FWD_Q1] Crown Castle Q1 2026 Form 10-Q | PDF4–6/印刷3–5；note5 PDF14/印刷13；note13–14 PDF19–20
+https://investor.crowncastle.com/static-files/de60fca2-89d5-499d-899b-8e0a23030617
+[E_FWD_Q1_XBRL] SEC Companyfacts：Crown Castle 2025年度及2026Q1原申报事实 | InterestPaidNet / InterestCostsCapitalized；accn0001051470-26-000059，2026Q1，filed2026-05-07
+https://data.sec.gov/api/xbrl/companyfacts/CIK0001051470.json
+[E_FWD_RESTRUCT_CLASS] Crown Castle 2025 Form 10-K | 2025 10K PDF89/印刷89；Q1更新已由E_FWD_Q1 note13–14支持
+https://investor.crowncastle.com/static-files/68fb84e1-1dac-440d-96b4-55b9603e10dd
+[E_SP_ARO] Crown Castle 2025 Form 10-K | PDF/印刷p65、p73–74；p80–82税务
+https://investor.crowncastle.com/static-files/68fb84e1-1dac-440d-96b4-55b9603e10dd
+[E_SP_LEASE] Crown Castle 2025 Form 10-K | PDF/印刷p58、p64、p75、p85、p87；note14
+https://investor.crowncastle.com/static-files/68fb84e1-1dac-440d-96b4-55b9603e10dd
+[E_SP_Q1CFO] Crown Castle Q1 2026 Form 10-Q | PDF6/印刷p5，2026Q1/2025Q1现金流表；PDF19–20/印刷p18–19，note13重组事项
+https://investor.crowncastle.com/static-files/de60fca2-89d5-499d-899b-8e0a23030617
+[E_SP_RATIOS] S&amp;P Corporate Methodology: Ratios And Adjustments | 原发2019-04-01，2025-12-17重发，PDF7 ¶31–35；17–25 ¶86–137；44–45 ¶223–225
+https://www.maalot.co.il/Publications/MT20251223092257.pdf
+[E_SP_SCOPE] Crown Castle 2025 Form 10-K | note1/PDF及印刷p62；p60、p87–88
+https://investor.crowncastle.com/static-files/68fb84e1-1dac-440d-96b4-55b9603e10dd
+[E_DEV_CASH_CONTRACT] Crown Castle Q1 2026 Supplemental Information | PDF13–14
+https://investor.crowncastle.com/static-files/38f6a584-60a8-452d-bfd2-a44103aeec82
+[E_DEV_CORP] Corporate Methodology | PDF4–12、21–22、24–28、30–44、47–50；Tables1/2/3/5/14–19/21–25及¶40–50/91–92/112–125/136–191
+https://www.maalot.co.il/Publications/MT20250709153825.pdf
+[E_DEV_CP] Crown Castle 2025 Form 10-K | PDF4–8、17–19、36–38；Q1 supplement另见E_DEV_CASH_CONTRACT
+https://investor.crowncastle.com/static-files/68fb84e1-1dac-440d-96b4-55b9603e10dd
+[E_DEV_DI] S&amp;P Sector-Specific Corporate Methodology — Digital Infrastructure | PDF61–63、68–71、73、76–77
+https://www.maalot.co.il/Publications/MT20251012123218.pdf
+[E_DEV_FACE] Crown Castle Q1 2026 Supplemental Information | PDF15/印14，Capitalization Overview，Face Value
+https://investor.crowncastle.com/static-files/38f6a584-60a8-452d-bfd2-a44103aeec82
+[E_DEV_NOTE] Crown Castle Q1 2026 Form 10-Q | 2026Q1 10Q PDF13–14，Debt and Other Obligations
+https://investor.crowncastle.com/static-files/de60fca2-89d5-499d-899b-8e0a23030617
+[E_DEV_NOTE_GUAR] Crown Castle 2025 Form 10-K | PDF75、77–79，Senior Notes/Securitized Debt
+https://investor.crowncastle.com/static-files/68fb84e1-1dac-440d-96b4-55b9603e10dd
+[E_DEV_TOWER_RIGHTS] Crown Castle 2025 Form 10-K | PDF4、7、17–18及77–79
+https://investor.crowncastle.com/static-files/68fb84e1-1dac-440d-96b4-55b9603e10dd
+[E_R109_FRP_TABLE] Corporate Methodology | PDF29–36/¶105、108、110、116–125/Tables17–19
+https://www.maalot.co.il/Publications/MT20250709153825.pdf
+[E_R109_MODIFIERS] Corporate Methodology | PDF8/Table5脚注4–7；PDF38–43/Tables21–23；PDF49–50/¶186–191
+https://www.maalot.co.il/Publications/MT20250709153825.pdf
+[E_R109_NOTE_ID] Crown Castle Q1 2026 Form 10-Q | PDF13–14；另S25 PDF75/78与S_SP_Q1 PDF15交叉核
+https://investor.crowncastle.com/static-files/de60fca2-89d5-499d-899b-8e0a23030617
+[E_R109_RECOVERY] Recovery Rating Criteria For Corporate Issuers | PDF1、4、10–14、16–17、23、39、44/¶3、21–28、55–83、90–99/Appendix4/G
+https://www.maalot.co.il/Publications/MT20260405084138.pdf
+[E_DEV_PROXY] Crown Castle 2026 DEF14A（2026年股东会；完整传输HTML） | 完整HTML提取行1706–1732、1882–1907、2091–2112、4909–5008；印18–27/75–76相应部分
+https://investor.crowncastle.com/node/29011/html
+[E_DEV_COUNTRY] Country Risk Assessments Update: June 2026 | 内嵌文章元数据June17及Table1表头/美国行
+https://spratings.spglobal.com/ratings/en/regulatory/article/-/view/type/HTML/id/3582048
+[E_R109_METHOD_LIMIT] Corporate Methodology | PDF49/¶186；未核法域适用性关联另见E_R109_RECOVERY
+https://www.maalot.co.il/Publications/MT20250709153825.pdf
+[E24ORIG] Crown Castle 2024 Form 10-K（原报） | 原报 p61 合并损益；note 14/p88–89 segment results，分部表p89
+https://investor.crowncastle.com/static-files/baed4489-6578-4e32-81e6-a084eea66a02
+[E25PL] Crown Castle 2025 Form 10-K | 印刷及 PDF p59，Consolidated Statement of Operations and Comprehensive Income
+https://investor.crowncastle.com/static-files/68fb84e1-1dac-440d-96b4-55b9603e10dd
+[E25HFS] Crown Castle 2025 Form 10-K | note 3，印刷及 PDF p71–72，尤其 p72 资产负债、损益及脚注 (b)(c)
+https://investor.crowncastle.com/static-files/68fb84e1-1dac-440d-96b4-55b9603e10dd
+[EQ125] Crown Castle Q1 2025 Form 10-Q 原报 | note 3，2025-03-31 held-for-sale table
+https://www.sec.gov/Archives/edgar/data/1051470/000105147025000141/cci-20250331.htm
+[ESECSALE] Crown Castle 2025-06-04 SEC comment-response letter | 公司回复 comment 2；ASC205-20-45-3A、税项及830损失/819准备/11售出费用
+https://www.sec.gov/Archives/edgar/data/1051470/000105147025000154/filename1.htm
+[EQ126HFS] Crown Castle Q1 2026 Form 10-Q | note 3 印刷 p9/PDF p10，2026/2025 比较损益、准备表、脚注 (c)
+https://investor.crowncastle.com/static-files/de60fca2-89d5-499d-899b-8e0a23030617
+[E_SP_LAND] Crown Castle Q4 2025 Supplemental Information | PDF14/印刷p13：GROUND INTEREST OVERVIEW及脚注(e)–(i)
+https://investor.crowncastle.com/static-files/bea23792-6649-4b95-9395-aa837e68396c
+[E_SP_RENEW] Crown Castle Q4 2025 Supplemental Information | PDF13/印刷p12；TENANT OVERVIEW及脚注(a)–(f)
+https://investor.crowncastle.com/static-files/bea23792-6649-4b95-9395-aa837e68396c</a:t>
+            </a:r>
+            <a:endParaRPr lang="en-US" dirty="0"/>
+          </a:p>
+        </p:txBody>
+      </p:sp>
+      <p:sp>
+        <p:nvSpPr>
+          <p:cNvPr id="4" name="Slide Number Placeholder 3"/>
+          <p:cNvSpPr>
+            <a:spLocks noGrp="1"/>
+          </p:cNvSpPr>
+          <p:nvPr>
+            <p:ph type="sldNum" sz="quarter" idx="10"/>
+          </p:nvPr>
+        </p:nvSpPr>
+        <p:spPr/>
+        <p:txBody>
+          <a:bodyPr/>
+          <a:lstStyle/>
+          <a:p>
+            <a:fld id="{F7021451-1387-4CA6-816F-3879F97B5CBC}" type="slidenum">
+              <a:rPr lang="en-US"/>
+              <a:t>17</a:t>
             </a:fld>
             <a:endParaRPr lang="en-US"/>
           </a:p>
@@ -6753,7 +6933,7 @@
                   <a:srgbClr val="213B45"/>
                 </a:solidFill>
               </a:rPr>
-              <a:t>新增证据会明确改变哪些判断</a:t>
+              <a:t>新增证据会明确改变哪些判断 1/2</a:t>
             </a:r>
             <a:endParaRPr lang="en-US" sz="2700" dirty="0"/>
           </a:p>
@@ -6932,6 +7112,451 @@
                 </a:solidFill>
               </a:rPr>
               <a:t>回收。两处公开版本差异继续保留，正式桥未取得前不强行平账。</a:t>
+            </a:r>
+            <a:endParaRPr lang="en-US" sz="1800" dirty="0"/>
+          </a:p>
+        </p:txBody>
+      </p:sp>
+      <p:sp>
+        <p:nvSpPr>
+          <p:cNvPr id="5" name="Text 3"/>
+          <p:cNvSpPr/>
+          <p:nvPr/>
+        </p:nvSpPr>
+        <p:spPr>
+          <a:xfrm>
+            <a:off x="594360" y="5321808"/>
+            <a:ext cx="10972800" cy="365760"/>
+          </a:xfrm>
+          <a:prstGeom prst="rect">
+            <a:avLst/>
+          </a:prstGeom>
+          <a:noFill/>
+          <a:ln/>
+        </p:spPr>
+        <p:txBody>
+          <a:bodyPr wrap="square" lIns="0" tIns="0" rIns="0" bIns="0" rtlCol="0" anchor="t"/>
+          <a:lstStyle/>
+          <a:p>
+            <a:pPr indent="0" marL="0">
+              <a:lnSpc>
+                <a:spcPct val="100000"/>
+              </a:lnSpc>
+              <a:buNone/>
+            </a:pPr>
+            <a:r>
+              <a:rPr lang="en-US" sz="1100" dirty="0">
+                <a:solidFill>
+                  <a:srgbClr val="213B45"/>
+                </a:solidFill>
+              </a:rPr>
+              <a:t>[F05] conditional / [FF_R109_ISSUER] conditional / [FF_R109_NOTE] </a:t>
+            </a:r>
+            <a:endParaRPr lang="en-US" sz="1100" dirty="0"/>
+          </a:p>
+          <a:p>
+            <a:pPr indent="0" marL="0">
+              <a:lnSpc>
+                <a:spcPct val="100000"/>
+              </a:lnSpc>
+              <a:buNone/>
+            </a:pPr>
+            <a:r>
+              <a:rPr lang="en-US" sz="1100" dirty="0">
+                <a:solidFill>
+                  <a:srgbClr val="213B45"/>
+                </a:solidFill>
+              </a:rPr>
+              <a:t>conditional / [F10] unresolved / [FF_FORWARD_STRESS] conditional</a:t>
+            </a:r>
+            <a:endParaRPr lang="en-US" sz="1100" dirty="0"/>
+          </a:p>
+        </p:txBody>
+      </p:sp>
+      <p:sp>
+        <p:nvSpPr>
+          <p:cNvPr id="6" name="Text 4"/>
+          <p:cNvSpPr/>
+          <p:nvPr/>
+        </p:nvSpPr>
+        <p:spPr>
+          <a:xfrm>
+            <a:off x="594360" y="5715000"/>
+            <a:ext cx="10972800" cy="731520"/>
+          </a:xfrm>
+          <a:prstGeom prst="rect">
+            <a:avLst/>
+          </a:prstGeom>
+          <a:noFill/>
+          <a:ln/>
+        </p:spPr>
+        <p:txBody>
+          <a:bodyPr wrap="square" lIns="0" tIns="0" rIns="0" bIns="0" rtlCol="0" anchor="t"/>
+          <a:lstStyle/>
+          <a:p>
+            <a:pPr indent="0" marL="0">
+              <a:lnSpc>
+                <a:spcPct val="100000"/>
+              </a:lnSpc>
+              <a:buNone/>
+            </a:pPr>
+            <a:r>
+              <a:rPr lang="en-US" sz="1000" dirty="0">
+                <a:solidFill>
+                  <a:srgbClr val="586874"/>
+                </a:solidFill>
+              </a:rPr>
+              <a:t>底稿判断 5 项；来源 17 份。</a:t>
+            </a:r>
+            <a:endParaRPr lang="en-US" sz="1000" dirty="0"/>
+          </a:p>
+          <a:p>
+            <a:pPr indent="0" marL="0">
+              <a:lnSpc>
+                <a:spcPct val="100000"/>
+              </a:lnSpc>
+              <a:buNone/>
+            </a:pPr>
+            <a:r>
+              <a:rPr lang="en-US" sz="1000" dirty="0">
+                <a:solidFill>
+                  <a:srgbClr val="586874"/>
+                </a:solidFill>
+              </a:rPr>
+              <a:t>完整底稿ID、原文定位、URL见本页备注；完整方法和明细见同名 Word/Excel。</a:t>
+            </a:r>
+            <a:endParaRPr lang="en-US" sz="1000" dirty="0"/>
+          </a:p>
+        </p:txBody>
+      </p:sp>
+    </p:spTree>
+  </p:cSld>
+  <p:clrMapOvr>
+    <a:masterClrMapping/>
+  </p:clrMapOvr>
+</p:sld>
+</file>
+
+<file path=ppt/slides/slide17.xml><?xml version="1.0" encoding="utf-8"?>
+<p:sld xmlns:a="http://schemas.openxmlformats.org/drawingml/2006/main" xmlns:r="http://schemas.openxmlformats.org/officeDocument/2006/relationships" xmlns:p="http://schemas.openxmlformats.org/presentationml/2006/main">
+  <p:cSld name="Slide 17">
+    <p:bg>
+      <p:bgPr>
+        <a:solidFill>
+          <a:srgbClr val="F5F7F6"/>
+        </a:solidFill>
+      </p:bgPr>
+    </p:bg>
+    <p:spTree>
+      <p:nvGrpSpPr>
+        <p:cNvPr id="1" name=""/>
+        <p:cNvGrpSpPr/>
+        <p:nvPr/>
+      </p:nvGrpSpPr>
+      <p:grpSpPr>
+        <a:xfrm>
+          <a:off x="0" y="0"/>
+          <a:ext cx="0" cy="0"/>
+          <a:chOff x="0" y="0"/>
+          <a:chExt cx="0" cy="0"/>
+        </a:xfrm>
+      </p:grpSpPr>
+      <p:sp>
+        <p:nvSpPr>
+          <p:cNvPr id="2" name="Text 0"/>
+          <p:cNvSpPr/>
+          <p:nvPr/>
+        </p:nvSpPr>
+        <p:spPr>
+          <a:xfrm>
+            <a:off x="548640" y="365760"/>
+            <a:ext cx="11064240" cy="731520"/>
+          </a:xfrm>
+          <a:prstGeom prst="rect">
+            <a:avLst/>
+          </a:prstGeom>
+          <a:noFill/>
+          <a:ln/>
+        </p:spPr>
+        <p:txBody>
+          <a:bodyPr wrap="square" lIns="0" tIns="0" rIns="0" bIns="0" rtlCol="0" anchor="t"/>
+          <a:lstStyle/>
+          <a:p>
+            <a:pPr indent="0" marL="0">
+              <a:lnSpc>
+                <a:spcPct val="100000"/>
+              </a:lnSpc>
+              <a:buNone/>
+            </a:pPr>
+            <a:r>
+              <a:rPr lang="en-US" sz="2700" b="1" dirty="0">
+                <a:solidFill>
+                  <a:srgbClr val="213B45"/>
+                </a:solidFill>
+              </a:rPr>
+              <a:t>新增证据会明确改变哪些判断 2/2</a:t>
+            </a:r>
+            <a:endParaRPr lang="en-US" sz="2700" dirty="0"/>
+          </a:p>
+        </p:txBody>
+      </p:sp>
+      <p:sp>
+        <p:nvSpPr>
+          <p:cNvPr id="3" name="Text 1"/>
+          <p:cNvSpPr/>
+          <p:nvPr/>
+        </p:nvSpPr>
+        <p:spPr>
+          <a:xfrm>
+            <a:off x="548640" y="6473952"/>
+            <a:ext cx="11064240" cy="182880"/>
+          </a:xfrm>
+          <a:prstGeom prst="rect">
+            <a:avLst/>
+          </a:prstGeom>
+          <a:noFill/>
+          <a:ln/>
+        </p:spPr>
+        <p:txBody>
+          <a:bodyPr wrap="square" lIns="0" tIns="0" rIns="0" bIns="0" rtlCol="0" anchor="ctr"/>
+          <a:lstStyle/>
+          <a:p>
+            <a:pPr indent="0" marL="0">
+              <a:buNone/>
+            </a:pPr>
+            <a:r>
+              <a:rPr lang="en-US" sz="900" dirty="0">
+                <a:solidFill>
+                  <a:srgbClr val="586874"/>
+                </a:solidFill>
+              </a:rPr>
+              <a:t>Crown Castle Inc. and subsidiaries  |  2025-12-31  |  crown-castle-2025-public-4  |  17</a:t>
+            </a:r>
+            <a:endParaRPr lang="en-US" sz="900" dirty="0"/>
+          </a:p>
+        </p:txBody>
+      </p:sp>
+      <p:sp>
+        <p:nvSpPr>
+          <p:cNvPr id="4" name="Text 2"/>
+          <p:cNvSpPr/>
+          <p:nvPr/>
+        </p:nvSpPr>
+        <p:spPr>
+          <a:xfrm>
+            <a:off x="594360" y="1417320"/>
+            <a:ext cx="10972800" cy="3794760"/>
+          </a:xfrm>
+          <a:prstGeom prst="rect">
+            <a:avLst/>
+          </a:prstGeom>
+          <a:noFill/>
+          <a:ln/>
+        </p:spPr>
+        <p:txBody>
+          <a:bodyPr wrap="square" lIns="0" tIns="0" rIns="0" bIns="0" rtlCol="0" anchor="t"/>
+          <a:lstStyle/>
+          <a:p>
+            <a:pPr indent="0" marL="0">
+              <a:lnSpc>
+                <a:spcPct val="100000"/>
+              </a:lnSpc>
+              <a:buNone/>
+            </a:pPr>
+            <a:r>
+              <a:rPr lang="en-US" sz="1800" dirty="0">
+                <a:solidFill>
+                  <a:srgbClr val="1F2933"/>
+                </a:solidFill>
+              </a:rPr>
+              <a:t>采用S&amp;P全球尺度作条件性信用研究，信息截止2026-06-30；不是机构已发表评级。本案</a:t>
+            </a:r>
+            <a:endParaRPr lang="en-US" sz="1800" dirty="0"/>
+          </a:p>
+          <a:p>
+            <a:pPr indent="0" marL="0">
+              <a:lnSpc>
+                <a:spcPct val="100000"/>
+              </a:lnSpc>
+              <a:buNone/>
+            </a:pPr>
+            <a:r>
+              <a:rPr lang="en-US" sz="1800" dirty="0">
+                <a:solidFill>
+                  <a:srgbClr val="1F2933"/>
+                </a:solidFill>
+              </a:rPr>
+              <a:t>采用版本：Corporate Methodology（2025-07-07重发）；</a:t>
+            </a:r>
+            <a:endParaRPr lang="en-US" sz="1800" dirty="0"/>
+          </a:p>
+          <a:p>
+            <a:pPr indent="0" marL="0">
+              <a:lnSpc>
+                <a:spcPct val="100000"/>
+              </a:lnSpc>
+              <a:buNone/>
+            </a:pPr>
+            <a:r>
+              <a:rPr lang="en-US" sz="1800" dirty="0">
+                <a:solidFill>
+                  <a:srgbClr val="1F2933"/>
+                </a:solidFill>
+              </a:rPr>
+              <a:t>Corporate Methodology: Ratios And Adjustments（</a:t>
+            </a:r>
+            <a:endParaRPr lang="en-US" sz="1800" dirty="0"/>
+          </a:p>
+          <a:p>
+            <a:pPr indent="0" marL="0">
+              <a:lnSpc>
+                <a:spcPct val="100000"/>
+              </a:lnSpc>
+              <a:buNone/>
+            </a:pPr>
+            <a:r>
+              <a:rPr lang="en-US" sz="1800" dirty="0">
+                <a:solidFill>
+                  <a:srgbClr val="1F2933"/>
+                </a:solidFill>
+              </a:rPr>
+              <a:t>2025-12-17重发）；Sector-Specific Corporate </a:t>
+            </a:r>
+            <a:endParaRPr lang="en-US" sz="1800" dirty="0"/>
+          </a:p>
+          <a:p>
+            <a:pPr indent="0" marL="0">
+              <a:lnSpc>
+                <a:spcPct val="100000"/>
+              </a:lnSpc>
+              <a:buNone/>
+            </a:pPr>
+            <a:r>
+              <a:rPr lang="en-US" sz="1800" dirty="0">
+                <a:solidFill>
+                  <a:srgbClr val="1F2933"/>
+                </a:solidFill>
+              </a:rPr>
+              <a:t>Methodology—Digital Infrastructure（2025-09</a:t>
+            </a:r>
+            <a:endParaRPr lang="en-US" sz="1800" dirty="0"/>
+          </a:p>
+          <a:p>
+            <a:pPr indent="0" marL="0">
+              <a:lnSpc>
+                <a:spcPct val="100000"/>
+              </a:lnSpc>
+              <a:buNone/>
+            </a:pPr>
+            <a:r>
+              <a:rPr lang="en-US" sz="1800" dirty="0">
+                <a:solidFill>
+                  <a:srgbClr val="1F2933"/>
+                </a:solidFill>
+              </a:rPr>
+              <a:t>-26）；Liquidity Descriptors For Global </a:t>
+            </a:r>
+            <a:endParaRPr lang="en-US" sz="1800" dirty="0"/>
+          </a:p>
+          <a:p>
+            <a:pPr indent="0" marL="0">
+              <a:lnSpc>
+                <a:spcPct val="100000"/>
+              </a:lnSpc>
+              <a:buNone/>
+            </a:pPr>
+            <a:r>
+              <a:rPr lang="en-US" sz="1800" dirty="0">
+                <a:solidFill>
+                  <a:srgbClr val="1F2933"/>
+                </a:solidFill>
+              </a:rPr>
+              <a:t>Corporate Issuers（2024-11-19重发）；Recovery </a:t>
+            </a:r>
+            <a:endParaRPr lang="en-US" sz="1800" dirty="0"/>
+          </a:p>
+          <a:p>
+            <a:pPr indent="0" marL="0">
+              <a:lnSpc>
+                <a:spcPct val="100000"/>
+              </a:lnSpc>
+              <a:buNone/>
+            </a:pPr>
+            <a:r>
+              <a:rPr lang="en-US" sz="1800" dirty="0">
+                <a:solidFill>
+                  <a:srgbClr val="1F2933"/>
+                </a:solidFill>
+              </a:rPr>
+              <a:t>Rating Criteria For Corporate Issuers（2026-03</a:t>
+            </a:r>
+            <a:endParaRPr lang="en-US" sz="1800" dirty="0"/>
+          </a:p>
+          <a:p>
+            <a:pPr indent="0" marL="0">
+              <a:lnSpc>
+                <a:spcPct val="100000"/>
+              </a:lnSpc>
+              <a:buNone/>
+            </a:pPr>
+            <a:r>
+              <a:rPr lang="en-US" sz="1800" dirty="0">
+                <a:solidFill>
+                  <a:srgbClr val="1F2933"/>
+                </a:solidFill>
+              </a:rPr>
+              <a:t>-31）；Reflecting Subordination Risk In </a:t>
+            </a:r>
+            <a:endParaRPr lang="en-US" sz="1800" dirty="0"/>
+          </a:p>
+          <a:p>
+            <a:pPr indent="0" marL="0">
+              <a:lnSpc>
+                <a:spcPct val="100000"/>
+              </a:lnSpc>
+              <a:buNone/>
+            </a:pPr>
+            <a:r>
+              <a:rPr lang="en-US" sz="1800" dirty="0">
+                <a:solidFill>
+                  <a:srgbClr val="1F2933"/>
+                </a:solidFill>
+              </a:rPr>
+              <a:t>Corporate Issue Ratings（2026-03-31重发）。2026年10月</a:t>
+            </a:r>
+            <a:endParaRPr lang="en-US" sz="1800" dirty="0"/>
+          </a:p>
+          <a:p>
+            <a:pPr indent="0" marL="0">
+              <a:lnSpc>
+                <a:spcPct val="100000"/>
+              </a:lnSpc>
+              <a:buNone/>
+            </a:pPr>
+            <a:r>
+              <a:rPr lang="en-US" sz="1800" dirty="0">
+                <a:solidFill>
+                  <a:srgbClr val="1F2933"/>
+                </a:solidFill>
+              </a:rPr>
+              <a:t>整理不将截止日后修订倒填历史信息窗；专门治理分类、六月实际资金资格、截止日主权/T&amp;C及回收</a:t>
+            </a:r>
+            <a:endParaRPr lang="en-US" sz="1800" dirty="0"/>
+          </a:p>
+          <a:p>
+            <a:pPr indent="0" marL="0">
+              <a:lnSpc>
+                <a:spcPct val="100000"/>
+              </a:lnSpc>
+              <a:buNone/>
+            </a:pPr>
+            <a:r>
+              <a:rPr lang="en-US" sz="1800" dirty="0">
+                <a:solidFill>
+                  <a:srgbClr val="1F2933"/>
+                </a:solidFill>
+              </a:rPr>
+              <a:t>法域仍分别待核。</a:t>
             </a:r>
             <a:endParaRPr lang="en-US" sz="1800" dirty="0"/>
           </a:p>

</xml_diff>